<commit_message>
Complete manual rev. 2 sync in workshop materials (Use recommended button)
- Pre-lab §2.6: one paragraph on the Use recommended button and its
  ~800-total-updates epoch choice
- Lab manual Part E1: Use recommended as the primary starting point,
  manual defaults table kept as the alternative
- Lesson slides: hyperparameter card now leads with Use recommended;
  training-demo bullet updated (was 'Defaults everywhere'); deploy-demo
  gains the serial-commands bullet (get ood / set ood defaults)
- Regenerated prelab.docx, labmanual.docx, and the Canva-ready pptx
</commit_message>
<xml_diff>
--- a/workshop/Edge_AI_Vision_Workshop_Slides.pptx
+++ b/workshop/Edge_AI_Vision_Workshop_Slides.pptx
@@ -4907,7 +4907,7 @@
                 <a:ea typeface="Arial" pitchFamily="34" charset="-122"/>
                 <a:cs typeface="Arial" pitchFamily="34" charset="-120"/>
               </a:rPr>
-              <a:t>START FROM DEFAULTS</a:t>
+              <a:t>START FROM RECOMMENDED</a:t>
             </a:r>
             <a:endParaRPr lang="en-US" sz="850" dirty="0"/>
           </a:p>
@@ -4988,7 +4988,7 @@
                 <a:ea typeface="Arial" pitchFamily="34" charset="-122"/>
                 <a:cs typeface="Arial" pitchFamily="34" charset="-120"/>
               </a:rPr>
-              <a:t>The defaults suit 96×96 grayscale input. In the project, the highest-leverage improvements come from the data, not from these values.</a:t>
+              <a:t>Use recommended applies the recommended hyperparameters automatically — epochs are chosen for ≈800 total updates. In the project, the highest-leverage improvements come from the data, not from these values.</a:t>
             </a:r>
             <a:endParaRPr lang="en-US" sz="1050" dirty="0"/>
           </a:p>
@@ -7880,7 +7880,7 @@
                 <a:ea typeface="Arial" pitchFamily="34" charset="-122"/>
                 <a:cs typeface="Arial" pitchFamily="34" charset="-120"/>
               </a:rPr>
-              <a:t>Defaults everywhere: 96 · grayscale · batch 16 · 20 epochs · lr 0.001 · 8/16 filters · 32 dense</a:t>
+              <a:t>Click Use recommended to apply the recommended hyperparameters (epochs chosen for ≈800 total updates)</a:t>
             </a:r>
             <a:endParaRPr lang="en-US" sz="1300" dirty="0"/>
           </a:p>
@@ -8631,7 +8631,7 @@
         <p:spPr>
           <a:xfrm>
             <a:off x="566928" y="1828800"/>
-            <a:ext cx="5486400" cy="2560320"/>
+            <a:ext cx="5486400" cy="2926080"/>
           </a:xfrm>
           <a:prstGeom prst="rect">
             <a:avLst/>
@@ -8735,6 +8735,30 @@
                 <a:cs typeface="Arial" pitchFamily="34" charset="-120"/>
               </a:rPr>
               <a:t>Upload → Serial Monitor → the board classifies independently</a:t>
+            </a:r>
+            <a:endParaRPr lang="en-US" sz="1250" dirty="0"/>
+          </a:p>
+          <a:p>
+            <a:pPr algn="l" marL="177800" indent="-177800">
+              <a:lnSpc>
+                <a:spcPct val="112000"/>
+              </a:lnSpc>
+              <a:spcAft>
+                <a:spcPts val="800"/>
+              </a:spcAft>
+              <a:buSzPct val="100000"/>
+              <a:buChar char="•"/>
+            </a:pPr>
+            <a:r>
+              <a:rPr lang="en-US" sz="1250" dirty="0">
+                <a:solidFill>
+                  <a:srgbClr val="525252"/>
+                </a:solidFill>
+                <a:latin typeface="Arial" pitchFamily="34" charset="0"/>
+                <a:ea typeface="Arial" pitchFamily="34" charset="-122"/>
+                <a:cs typeface="Arial" pitchFamily="34" charset="-120"/>
+              </a:rPr>
+              <a:t>Serial Monitor commands set the output mode and OOD parameters — get ood reports the values; set ood 0.3 70.0 0.60 0.70 restores defaults</a:t>
             </a:r>
             <a:endParaRPr lang="en-US" sz="1250" dirty="0"/>
           </a:p>

</xml_diff>